<commit_message>
comparing research between GCN and flowpure.
</commit_message>
<xml_diff>
--- a/week_23.pptx
+++ b/week_23.pptx
@@ -8,6 +8,10 @@
     <p:sldId id="258" r:id="rId2"/>
     <p:sldId id="256" r:id="rId3"/>
     <p:sldId id="257" r:id="rId4"/>
+    <p:sldId id="259" r:id="rId5"/>
+    <p:sldId id="260" r:id="rId6"/>
+    <p:sldId id="261" r:id="rId7"/>
+    <p:sldId id="262" r:id="rId8"/>
   </p:sldIdLst>
   <p:sldSz cx="12192000" cy="6858000"/>
   <p:notesSz cx="6858000" cy="9144000"/>
@@ -261,7 +265,7 @@
           <a:p>
             <a:fld id="{BBEA7A2A-C4D1-4F21-A6CF-ADBDEFA8074E}" type="datetimeFigureOut">
               <a:rPr lang="zh-CN" altLang="en-US" smtClean="0"/>
-              <a:t>2026/8/31</a:t>
+              <a:t>2026/9/7</a:t>
             </a:fld>
             <a:endParaRPr lang="zh-CN" altLang="en-US"/>
           </a:p>
@@ -459,7 +463,7 @@
           <a:p>
             <a:fld id="{BBEA7A2A-C4D1-4F21-A6CF-ADBDEFA8074E}" type="datetimeFigureOut">
               <a:rPr lang="zh-CN" altLang="en-US" smtClean="0"/>
-              <a:t>2026/8/31</a:t>
+              <a:t>2026/9/7</a:t>
             </a:fld>
             <a:endParaRPr lang="zh-CN" altLang="en-US"/>
           </a:p>
@@ -667,7 +671,7 @@
           <a:p>
             <a:fld id="{BBEA7A2A-C4D1-4F21-A6CF-ADBDEFA8074E}" type="datetimeFigureOut">
               <a:rPr lang="zh-CN" altLang="en-US" smtClean="0"/>
-              <a:t>2026/8/31</a:t>
+              <a:t>2026/9/7</a:t>
             </a:fld>
             <a:endParaRPr lang="zh-CN" altLang="en-US"/>
           </a:p>
@@ -865,7 +869,7 @@
           <a:p>
             <a:fld id="{BBEA7A2A-C4D1-4F21-A6CF-ADBDEFA8074E}" type="datetimeFigureOut">
               <a:rPr lang="zh-CN" altLang="en-US" smtClean="0"/>
-              <a:t>2026/8/31</a:t>
+              <a:t>2026/9/7</a:t>
             </a:fld>
             <a:endParaRPr lang="zh-CN" altLang="en-US"/>
           </a:p>
@@ -1140,7 +1144,7 @@
           <a:p>
             <a:fld id="{BBEA7A2A-C4D1-4F21-A6CF-ADBDEFA8074E}" type="datetimeFigureOut">
               <a:rPr lang="zh-CN" altLang="en-US" smtClean="0"/>
-              <a:t>2026/8/31</a:t>
+              <a:t>2026/9/7</a:t>
             </a:fld>
             <a:endParaRPr lang="zh-CN" altLang="en-US"/>
           </a:p>
@@ -1405,7 +1409,7 @@
           <a:p>
             <a:fld id="{BBEA7A2A-C4D1-4F21-A6CF-ADBDEFA8074E}" type="datetimeFigureOut">
               <a:rPr lang="zh-CN" altLang="en-US" smtClean="0"/>
-              <a:t>2026/8/31</a:t>
+              <a:t>2026/9/7</a:t>
             </a:fld>
             <a:endParaRPr lang="zh-CN" altLang="en-US"/>
           </a:p>
@@ -1817,7 +1821,7 @@
           <a:p>
             <a:fld id="{BBEA7A2A-C4D1-4F21-A6CF-ADBDEFA8074E}" type="datetimeFigureOut">
               <a:rPr lang="zh-CN" altLang="en-US" smtClean="0"/>
-              <a:t>2026/8/31</a:t>
+              <a:t>2026/9/7</a:t>
             </a:fld>
             <a:endParaRPr lang="zh-CN" altLang="en-US"/>
           </a:p>
@@ -1958,7 +1962,7 @@
           <a:p>
             <a:fld id="{BBEA7A2A-C4D1-4F21-A6CF-ADBDEFA8074E}" type="datetimeFigureOut">
               <a:rPr lang="zh-CN" altLang="en-US" smtClean="0"/>
-              <a:t>2026/8/31</a:t>
+              <a:t>2026/9/7</a:t>
             </a:fld>
             <a:endParaRPr lang="zh-CN" altLang="en-US"/>
           </a:p>
@@ -2071,7 +2075,7 @@
           <a:p>
             <a:fld id="{BBEA7A2A-C4D1-4F21-A6CF-ADBDEFA8074E}" type="datetimeFigureOut">
               <a:rPr lang="zh-CN" altLang="en-US" smtClean="0"/>
-              <a:t>2026/8/31</a:t>
+              <a:t>2026/9/7</a:t>
             </a:fld>
             <a:endParaRPr lang="zh-CN" altLang="en-US"/>
           </a:p>
@@ -2382,7 +2386,7 @@
           <a:p>
             <a:fld id="{BBEA7A2A-C4D1-4F21-A6CF-ADBDEFA8074E}" type="datetimeFigureOut">
               <a:rPr lang="zh-CN" altLang="en-US" smtClean="0"/>
-              <a:t>2026/8/31</a:t>
+              <a:t>2026/9/7</a:t>
             </a:fld>
             <a:endParaRPr lang="zh-CN" altLang="en-US"/>
           </a:p>
@@ -2670,7 +2674,7 @@
           <a:p>
             <a:fld id="{BBEA7A2A-C4D1-4F21-A6CF-ADBDEFA8074E}" type="datetimeFigureOut">
               <a:rPr lang="zh-CN" altLang="en-US" smtClean="0"/>
-              <a:t>2026/8/31</a:t>
+              <a:t>2026/9/7</a:t>
             </a:fld>
             <a:endParaRPr lang="zh-CN" altLang="en-US"/>
           </a:p>
@@ -2911,7 +2915,7 @@
           <a:p>
             <a:fld id="{BBEA7A2A-C4D1-4F21-A6CF-ADBDEFA8074E}" type="datetimeFigureOut">
               <a:rPr lang="zh-CN" altLang="en-US" smtClean="0"/>
-              <a:t>2026/8/31</a:t>
+              <a:t>2026/9/7</a:t>
             </a:fld>
             <a:endParaRPr lang="zh-CN" altLang="en-US"/>
           </a:p>
@@ -5342,6 +5346,1647 @@
 </p:sld>
 </file>
 
+<file path=ppt/slides/slide4.xml><?xml version="1.0" encoding="utf-8"?>
+<p:sld xmlns:a="http://schemas.openxmlformats.org/drawingml/2006/main" xmlns:r="http://schemas.openxmlformats.org/officeDocument/2006/relationships" xmlns:p="http://schemas.openxmlformats.org/presentationml/2006/main">
+  <p:cSld>
+    <p:spTree>
+      <p:nvGrpSpPr>
+        <p:cNvPr id="1" name=""/>
+        <p:cNvGrpSpPr/>
+        <p:nvPr/>
+      </p:nvGrpSpPr>
+      <p:grpSpPr>
+        <a:xfrm>
+          <a:off x="0" y="0"/>
+          <a:ext cx="0" cy="0"/>
+          <a:chOff x="0" y="0"/>
+          <a:chExt cx="0" cy="0"/>
+        </a:xfrm>
+      </p:grpSpPr>
+      <p:sp>
+        <p:nvSpPr>
+          <p:cNvPr id="2" name="标题 1">
+            <a:extLst>
+              <a:ext uri="{FF2B5EF4-FFF2-40B4-BE49-F238E27FC236}">
+                <a16:creationId xmlns:a16="http://schemas.microsoft.com/office/drawing/2014/main" id="{1CF03220-4C76-5122-1CEE-974247C39224}"/>
+              </a:ext>
+            </a:extLst>
+          </p:cNvPr>
+          <p:cNvSpPr>
+            <a:spLocks noGrp="1"/>
+          </p:cNvSpPr>
+          <p:nvPr>
+            <p:ph type="title"/>
+          </p:nvPr>
+        </p:nvSpPr>
+        <p:spPr/>
+        <p:txBody>
+          <a:bodyPr/>
+          <a:lstStyle/>
+          <a:p>
+            <a:r>
+              <a:rPr lang="zh-CN" altLang="en-US" dirty="0"/>
+              <a:t>当前</a:t>
+            </a:r>
+            <a:r>
+              <a:rPr lang="en-US" altLang="zh-CN" dirty="0" err="1"/>
+              <a:t>gcn</a:t>
+            </a:r>
+            <a:r>
+              <a:rPr lang="zh-CN" altLang="en-US" dirty="0"/>
+              <a:t>网络存在的问题</a:t>
+            </a:r>
+          </a:p>
+        </p:txBody>
+      </p:sp>
+      <p:sp>
+        <p:nvSpPr>
+          <p:cNvPr id="3" name="内容占位符 2">
+            <a:extLst>
+              <a:ext uri="{FF2B5EF4-FFF2-40B4-BE49-F238E27FC236}">
+                <a16:creationId xmlns:a16="http://schemas.microsoft.com/office/drawing/2014/main" id="{3E636A82-C5BE-35C5-E58F-5495B9A950F4}"/>
+              </a:ext>
+            </a:extLst>
+          </p:cNvPr>
+          <p:cNvSpPr>
+            <a:spLocks noGrp="1"/>
+          </p:cNvSpPr>
+          <p:nvPr>
+            <p:ph idx="1"/>
+          </p:nvPr>
+        </p:nvSpPr>
+        <p:spPr/>
+        <p:txBody>
+          <a:bodyPr/>
+          <a:lstStyle/>
+          <a:p>
+            <a:r>
+              <a:rPr lang="zh-CN" altLang="en-US" dirty="0"/>
+              <a:t>对小目标空间信息压缩过强</a:t>
+            </a:r>
+            <a:endParaRPr lang="en-US" altLang="zh-CN" dirty="0"/>
+          </a:p>
+          <a:p>
+            <a:r>
+              <a:rPr lang="en-US" altLang="zh-CN" dirty="0"/>
+              <a:t>64*64</a:t>
+            </a:r>
+            <a:r>
+              <a:rPr lang="zh-CN" altLang="en-US" dirty="0"/>
+              <a:t>层与</a:t>
+            </a:r>
+            <a:r>
+              <a:rPr lang="en-US" altLang="zh-CN" dirty="0"/>
+              <a:t>32*32</a:t>
+            </a:r>
+            <a:r>
+              <a:rPr lang="zh-CN" altLang="en-US" dirty="0"/>
+              <a:t>层统一使用</a:t>
+            </a:r>
+            <a:r>
+              <a:rPr lang="en-US" altLang="zh-CN" dirty="0"/>
+              <a:t>8*8*8</a:t>
+            </a:r>
+            <a:r>
+              <a:rPr lang="zh-CN" altLang="en-US" dirty="0"/>
+              <a:t>量化配置，不够合理</a:t>
+            </a:r>
+            <a:endParaRPr lang="en-US" altLang="zh-CN" dirty="0"/>
+          </a:p>
+          <a:p>
+            <a:r>
+              <a:rPr lang="en-US" altLang="zh-CN" dirty="0"/>
+              <a:t>Skip</a:t>
+            </a:r>
+            <a:r>
+              <a:rPr lang="zh-CN" altLang="en-US" dirty="0"/>
+              <a:t>码没有经过净化可能让对抗攻击绕过扩散</a:t>
+            </a:r>
+            <a:endParaRPr lang="en-US" altLang="zh-CN" dirty="0"/>
+          </a:p>
+          <a:p>
+            <a:endParaRPr lang="en-US" altLang="zh-CN" dirty="0"/>
+          </a:p>
+          <a:p>
+            <a:r>
+              <a:rPr lang="zh-CN" altLang="en-US" dirty="0"/>
+              <a:t>本次主要修改：</a:t>
+            </a:r>
+            <a:endParaRPr lang="en-US" altLang="zh-CN" dirty="0"/>
+          </a:p>
+          <a:p>
+            <a:r>
+              <a:rPr lang="zh-CN" altLang="zh-CN" dirty="0"/>
+              <a:t>64×64 skip：16×16×2 = 512 bit</a:t>
+            </a:r>
+            <a:endParaRPr lang="en-US" altLang="zh-CN" dirty="0"/>
+          </a:p>
+          <a:p>
+            <a:pPr lvl="0"/>
+            <a:r>
+              <a:rPr lang="zh-CN" altLang="zh-CN" dirty="0"/>
+              <a:t>用可学习卷积下采样替代 AdaptiveAvgPool</a:t>
+            </a:r>
+          </a:p>
+          <a:p>
+            <a:pPr lvl="0"/>
+            <a:r>
+              <a:rPr lang="zh-CN" altLang="zh-CN" dirty="0"/>
+              <a:t>用bilinear+3×3卷积替代nearest放大</a:t>
+            </a:r>
+          </a:p>
+          <a:p>
+            <a:endParaRPr lang="zh-CN" altLang="en-US" dirty="0"/>
+          </a:p>
+        </p:txBody>
+      </p:sp>
+    </p:spTree>
+    <p:extLst>
+      <p:ext uri="{BB962C8B-B14F-4D97-AF65-F5344CB8AC3E}">
+        <p14:creationId xmlns:p14="http://schemas.microsoft.com/office/powerpoint/2010/main" val="2718201597"/>
+      </p:ext>
+    </p:extLst>
+  </p:cSld>
+  <p:clrMapOvr>
+    <a:masterClrMapping/>
+  </p:clrMapOvr>
+</p:sld>
+</file>
+
+<file path=ppt/slides/slide5.xml><?xml version="1.0" encoding="utf-8"?>
+<p:sld xmlns:a="http://schemas.openxmlformats.org/drawingml/2006/main" xmlns:r="http://schemas.openxmlformats.org/officeDocument/2006/relationships" xmlns:p="http://schemas.openxmlformats.org/presentationml/2006/main">
+  <p:cSld>
+    <p:spTree>
+      <p:nvGrpSpPr>
+        <p:cNvPr id="1" name=""/>
+        <p:cNvGrpSpPr/>
+        <p:nvPr/>
+      </p:nvGrpSpPr>
+      <p:grpSpPr>
+        <a:xfrm>
+          <a:off x="0" y="0"/>
+          <a:ext cx="0" cy="0"/>
+          <a:chOff x="0" y="0"/>
+          <a:chExt cx="0" cy="0"/>
+        </a:xfrm>
+      </p:grpSpPr>
+      <p:sp>
+        <p:nvSpPr>
+          <p:cNvPr id="2" name="标题 1">
+            <a:extLst>
+              <a:ext uri="{FF2B5EF4-FFF2-40B4-BE49-F238E27FC236}">
+                <a16:creationId xmlns:a16="http://schemas.microsoft.com/office/drawing/2014/main" id="{4154057D-BD6B-01CB-EAF5-33845B805908}"/>
+              </a:ext>
+            </a:extLst>
+          </p:cNvPr>
+          <p:cNvSpPr>
+            <a:spLocks noGrp="1"/>
+          </p:cNvSpPr>
+          <p:nvPr>
+            <p:ph type="title"/>
+          </p:nvPr>
+        </p:nvSpPr>
+        <p:spPr/>
+        <p:txBody>
+          <a:bodyPr/>
+          <a:lstStyle/>
+          <a:p>
+            <a:r>
+              <a:rPr lang="zh-CN" altLang="en-US" dirty="0"/>
+              <a:t>净化率与原始</a:t>
+            </a:r>
+            <a:r>
+              <a:rPr lang="en-US" altLang="zh-CN" dirty="0" err="1"/>
+              <a:t>mAP</a:t>
+            </a:r>
+            <a:endParaRPr lang="zh-CN" altLang="en-US" dirty="0"/>
+          </a:p>
+        </p:txBody>
+      </p:sp>
+      <p:sp>
+        <p:nvSpPr>
+          <p:cNvPr id="3" name="内容占位符 2">
+            <a:extLst>
+              <a:ext uri="{FF2B5EF4-FFF2-40B4-BE49-F238E27FC236}">
+                <a16:creationId xmlns:a16="http://schemas.microsoft.com/office/drawing/2014/main" id="{D1499080-392C-2E02-34C0-2646BC9B3FFD}"/>
+              </a:ext>
+            </a:extLst>
+          </p:cNvPr>
+          <p:cNvSpPr>
+            <a:spLocks noGrp="1"/>
+          </p:cNvSpPr>
+          <p:nvPr>
+            <p:ph idx="1"/>
+          </p:nvPr>
+        </p:nvSpPr>
+        <p:spPr/>
+        <p:txBody>
+          <a:bodyPr/>
+          <a:lstStyle/>
+          <a:p>
+            <a:r>
+              <a:rPr lang="en-US" altLang="zh-CN" dirty="0" err="1"/>
+              <a:t>clean_reconstructed</a:t>
+            </a:r>
+            <a:r>
+              <a:rPr lang="en-US" altLang="zh-CN" dirty="0"/>
+              <a:t>  ≈ 0.5566 - 0.1962 = 0.3604</a:t>
+            </a:r>
+          </a:p>
+          <a:p>
+            <a:r>
+              <a:rPr lang="en-US" altLang="zh-CN" dirty="0" err="1"/>
+              <a:t>adv_reconstructed</a:t>
+            </a:r>
+            <a:r>
+              <a:rPr lang="en-US" altLang="zh-CN" dirty="0"/>
+              <a:t>    ≈ 0.0045 + 0.3532 = 0.3577</a:t>
+            </a:r>
+          </a:p>
+          <a:p>
+            <a:r>
+              <a:rPr lang="en-US" altLang="zh-CN" dirty="0"/>
+              <a:t>T=3 purified         ≈ 0.3577 - 0.0062 = 0.3515</a:t>
+            </a:r>
+          </a:p>
+          <a:p>
+            <a:r>
+              <a:rPr lang="en-US" altLang="zh-CN" dirty="0"/>
+              <a:t>T=5 purified         ≈ 0.3500</a:t>
+            </a:r>
+          </a:p>
+          <a:p>
+            <a:r>
+              <a:rPr lang="en-US" altLang="zh-CN" dirty="0"/>
+              <a:t>T=10 purified        ≈ 0.3467</a:t>
+            </a:r>
+            <a:endParaRPr lang="zh-CN" altLang="en-US" dirty="0"/>
+          </a:p>
+        </p:txBody>
+      </p:sp>
+      <p:graphicFrame>
+        <p:nvGraphicFramePr>
+          <p:cNvPr id="6" name="表格 5">
+            <a:extLst>
+              <a:ext uri="{FF2B5EF4-FFF2-40B4-BE49-F238E27FC236}">
+                <a16:creationId xmlns:a16="http://schemas.microsoft.com/office/drawing/2014/main" id="{EB2C41D5-4698-FF3C-3ADB-0F6B89F734AD}"/>
+              </a:ext>
+            </a:extLst>
+          </p:cNvPr>
+          <p:cNvGraphicFramePr>
+            <a:graphicFrameLocks noGrp="1"/>
+          </p:cNvGraphicFramePr>
+          <p:nvPr>
+            <p:extLst>
+              <p:ext uri="{D42A27DB-BD31-4B8C-83A1-F6EECF244321}">
+                <p14:modId xmlns:p14="http://schemas.microsoft.com/office/powerpoint/2010/main" val="3369597549"/>
+              </p:ext>
+            </p:extLst>
+          </p:nvPr>
+        </p:nvGraphicFramePr>
+        <p:xfrm>
+          <a:off x="838200" y="4603274"/>
+          <a:ext cx="10515600" cy="1463040"/>
+        </p:xfrm>
+        <a:graphic>
+          <a:graphicData uri="http://schemas.openxmlformats.org/drawingml/2006/table">
+            <a:tbl>
+              <a:tblPr>
+                <a:tableStyleId>{5C22544A-7EE6-4342-B048-85BDC9FD1C3A}</a:tableStyleId>
+              </a:tblPr>
+              <a:tblGrid>
+                <a:gridCol w="3505200">
+                  <a:extLst>
+                    <a:ext uri="{9D8B030D-6E8A-4147-A177-3AD203B41FA5}">
+                      <a16:colId xmlns:a16="http://schemas.microsoft.com/office/drawing/2014/main" val="2751826671"/>
+                    </a:ext>
+                  </a:extLst>
+                </a:gridCol>
+                <a:gridCol w="3505200">
+                  <a:extLst>
+                    <a:ext uri="{9D8B030D-6E8A-4147-A177-3AD203B41FA5}">
+                      <a16:colId xmlns:a16="http://schemas.microsoft.com/office/drawing/2014/main" val="1817868089"/>
+                    </a:ext>
+                  </a:extLst>
+                </a:gridCol>
+                <a:gridCol w="3505200">
+                  <a:extLst>
+                    <a:ext uri="{9D8B030D-6E8A-4147-A177-3AD203B41FA5}">
+                      <a16:colId xmlns:a16="http://schemas.microsoft.com/office/drawing/2014/main" val="3765328341"/>
+                    </a:ext>
+                  </a:extLst>
+                </a:gridCol>
+              </a:tblGrid>
+              <a:tr h="0">
+                <a:tc>
+                  <a:txBody>
+                    <a:bodyPr/>
+                    <a:lstStyle/>
+                    <a:p>
+                      <a:pPr>
+                        <a:buNone/>
+                      </a:pPr>
+                      <a:r>
+                        <a:rPr lang="zh-CN"/>
+                        <a:t>方法</a:t>
+                      </a:r>
+                    </a:p>
+                  </a:txBody>
+                  <a:tcPr anchor="ctr"/>
+                </a:tc>
+                <a:tc>
+                  <a:txBody>
+                    <a:bodyPr/>
+                    <a:lstStyle/>
+                    <a:p>
+                      <a:pPr>
+                        <a:buNone/>
+                      </a:pPr>
+                      <a:r>
+                        <a:rPr lang="zh-CN"/>
+                        <a:t>mAP50恢复率</a:t>
+                      </a:r>
+                    </a:p>
+                  </a:txBody>
+                  <a:tcPr anchor="ctr"/>
+                </a:tc>
+                <a:tc>
+                  <a:txBody>
+                    <a:bodyPr/>
+                    <a:lstStyle/>
+                    <a:p>
+                      <a:pPr>
+                        <a:buNone/>
+                      </a:pPr>
+                      <a:r>
+                        <a:rPr lang="zh-CN"/>
+                        <a:t>mAP50-95恢复率</a:t>
+                      </a:r>
+                    </a:p>
+                  </a:txBody>
+                  <a:tcPr anchor="ctr"/>
+                </a:tc>
+                <a:extLst>
+                  <a:ext uri="{0D108BD9-81ED-4DB2-BD59-A6C34878D82A}">
+                    <a16:rowId xmlns:a16="http://schemas.microsoft.com/office/drawing/2014/main" val="3845572006"/>
+                  </a:ext>
+                </a:extLst>
+              </a:tr>
+              <a:tr h="0">
+                <a:tc>
+                  <a:txBody>
+                    <a:bodyPr/>
+                    <a:lstStyle/>
+                    <a:p>
+                      <a:pPr>
+                        <a:buNone/>
+                      </a:pPr>
+                      <a:r>
+                        <a:rPr lang="zh-CN"/>
+                        <a:t>旧GCN-Skip，T=3</a:t>
+                      </a:r>
+                    </a:p>
+                  </a:txBody>
+                  <a:tcPr anchor="ctr"/>
+                </a:tc>
+                <a:tc>
+                  <a:txBody>
+                    <a:bodyPr/>
+                    <a:lstStyle/>
+                    <a:p>
+                      <a:pPr>
+                        <a:buNone/>
+                      </a:pPr>
+                      <a:r>
+                        <a:rPr lang="zh-CN"/>
+                        <a:t>57.5%</a:t>
+                      </a:r>
+                    </a:p>
+                  </a:txBody>
+                  <a:tcPr anchor="ctr"/>
+                </a:tc>
+                <a:tc>
+                  <a:txBody>
+                    <a:bodyPr/>
+                    <a:lstStyle/>
+                    <a:p>
+                      <a:pPr>
+                        <a:buNone/>
+                      </a:pPr>
+                      <a:r>
+                        <a:rPr lang="zh-CN"/>
+                        <a:t>52.8%</a:t>
+                      </a:r>
+                    </a:p>
+                  </a:txBody>
+                  <a:tcPr anchor="ctr"/>
+                </a:tc>
+                <a:extLst>
+                  <a:ext uri="{0D108BD9-81ED-4DB2-BD59-A6C34878D82A}">
+                    <a16:rowId xmlns:a16="http://schemas.microsoft.com/office/drawing/2014/main" val="4146193179"/>
+                  </a:ext>
+                </a:extLst>
+              </a:tr>
+              <a:tr h="0">
+                <a:tc>
+                  <a:txBody>
+                    <a:bodyPr/>
+                    <a:lstStyle/>
+                    <a:p>
+                      <a:pPr>
+                        <a:buNone/>
+                      </a:pPr>
+                      <a:r>
+                        <a:rPr lang="zh-CN"/>
+                        <a:t>FlowPure，2000步</a:t>
+                      </a:r>
+                    </a:p>
+                  </a:txBody>
+                  <a:tcPr anchor="ctr"/>
+                </a:tc>
+                <a:tc>
+                  <a:txBody>
+                    <a:bodyPr/>
+                    <a:lstStyle/>
+                    <a:p>
+                      <a:pPr>
+                        <a:buNone/>
+                      </a:pPr>
+                      <a:r>
+                        <a:rPr lang="zh-CN"/>
+                        <a:t>58.3%</a:t>
+                      </a:r>
+                    </a:p>
+                  </a:txBody>
+                  <a:tcPr anchor="ctr"/>
+                </a:tc>
+                <a:tc>
+                  <a:txBody>
+                    <a:bodyPr/>
+                    <a:lstStyle/>
+                    <a:p>
+                      <a:pPr>
+                        <a:buNone/>
+                      </a:pPr>
+                      <a:r>
+                        <a:rPr lang="zh-CN"/>
+                        <a:t>52.9%</a:t>
+                      </a:r>
+                    </a:p>
+                  </a:txBody>
+                  <a:tcPr anchor="ctr"/>
+                </a:tc>
+                <a:extLst>
+                  <a:ext uri="{0D108BD9-81ED-4DB2-BD59-A6C34878D82A}">
+                    <a16:rowId xmlns:a16="http://schemas.microsoft.com/office/drawing/2014/main" val="462973627"/>
+                  </a:ext>
+                </a:extLst>
+              </a:tr>
+              <a:tr h="0">
+                <a:tc>
+                  <a:txBody>
+                    <a:bodyPr/>
+                    <a:lstStyle/>
+                    <a:p>
+                      <a:pPr>
+                        <a:buNone/>
+                      </a:pPr>
+                      <a:r>
+                        <a:rPr lang="zh-CN"/>
+                        <a:t>新GCN-Skip，T=3</a:t>
+                      </a:r>
+                    </a:p>
+                  </a:txBody>
+                  <a:tcPr anchor="ctr"/>
+                </a:tc>
+                <a:tc>
+                  <a:txBody>
+                    <a:bodyPr/>
+                    <a:lstStyle/>
+                    <a:p>
+                      <a:pPr>
+                        <a:buNone/>
+                      </a:pPr>
+                      <a:r>
+                        <a:rPr lang="zh-CN"/>
+                        <a:t>62.9%</a:t>
+                      </a:r>
+                    </a:p>
+                  </a:txBody>
+                  <a:tcPr anchor="ctr"/>
+                </a:tc>
+                <a:tc>
+                  <a:txBody>
+                    <a:bodyPr/>
+                    <a:lstStyle/>
+                    <a:p>
+                      <a:pPr>
+                        <a:buNone/>
+                      </a:pPr>
+                      <a:r>
+                        <a:rPr lang="zh-CN" dirty="0"/>
+                        <a:t>58.5%</a:t>
+                      </a:r>
+                    </a:p>
+                  </a:txBody>
+                  <a:tcPr anchor="ctr"/>
+                </a:tc>
+                <a:extLst>
+                  <a:ext uri="{0D108BD9-81ED-4DB2-BD59-A6C34878D82A}">
+                    <a16:rowId xmlns:a16="http://schemas.microsoft.com/office/drawing/2014/main" val="2300120733"/>
+                  </a:ext>
+                </a:extLst>
+              </a:tr>
+            </a:tbl>
+          </a:graphicData>
+        </a:graphic>
+      </p:graphicFrame>
+    </p:spTree>
+    <p:extLst>
+      <p:ext uri="{BB962C8B-B14F-4D97-AF65-F5344CB8AC3E}">
+        <p14:creationId xmlns:p14="http://schemas.microsoft.com/office/powerpoint/2010/main" val="3404352825"/>
+      </p:ext>
+    </p:extLst>
+  </p:cSld>
+  <p:clrMapOvr>
+    <a:masterClrMapping/>
+  </p:clrMapOvr>
+</p:sld>
+</file>
+
+<file path=ppt/slides/slide6.xml><?xml version="1.0" encoding="utf-8"?>
+<p:sld xmlns:a="http://schemas.openxmlformats.org/drawingml/2006/main" xmlns:r="http://schemas.openxmlformats.org/officeDocument/2006/relationships" xmlns:p="http://schemas.openxmlformats.org/presentationml/2006/main">
+  <p:cSld>
+    <p:spTree>
+      <p:nvGrpSpPr>
+        <p:cNvPr id="1" name=""/>
+        <p:cNvGrpSpPr/>
+        <p:nvPr/>
+      </p:nvGrpSpPr>
+      <p:grpSpPr>
+        <a:xfrm>
+          <a:off x="0" y="0"/>
+          <a:ext cx="0" cy="0"/>
+          <a:chOff x="0" y="0"/>
+          <a:chExt cx="0" cy="0"/>
+        </a:xfrm>
+      </p:grpSpPr>
+      <p:sp>
+        <p:nvSpPr>
+          <p:cNvPr id="2" name="标题 1">
+            <a:extLst>
+              <a:ext uri="{FF2B5EF4-FFF2-40B4-BE49-F238E27FC236}">
+                <a16:creationId xmlns:a16="http://schemas.microsoft.com/office/drawing/2014/main" id="{ECBB55C7-2307-4600-E8D2-A01DA0CF56BD}"/>
+              </a:ext>
+            </a:extLst>
+          </p:cNvPr>
+          <p:cNvSpPr>
+            <a:spLocks noGrp="1"/>
+          </p:cNvSpPr>
+          <p:nvPr>
+            <p:ph type="title"/>
+          </p:nvPr>
+        </p:nvSpPr>
+        <p:spPr/>
+        <p:txBody>
+          <a:bodyPr/>
+          <a:lstStyle/>
+          <a:p>
+            <a:r>
+              <a:rPr lang="zh-CN" altLang="en-US" dirty="0"/>
+              <a:t>统一生成</a:t>
+            </a:r>
+            <a:r>
+              <a:rPr lang="en-US" altLang="zh-CN" dirty="0"/>
+              <a:t>PGD</a:t>
+            </a:r>
+            <a:r>
+              <a:rPr lang="zh-CN" altLang="en-US" dirty="0"/>
+              <a:t>对抗图像三次对比</a:t>
+            </a:r>
+          </a:p>
+        </p:txBody>
+      </p:sp>
+      <p:sp>
+        <p:nvSpPr>
+          <p:cNvPr id="3" name="内容占位符 2">
+            <a:extLst>
+              <a:ext uri="{FF2B5EF4-FFF2-40B4-BE49-F238E27FC236}">
+                <a16:creationId xmlns:a16="http://schemas.microsoft.com/office/drawing/2014/main" id="{CE4FDEEB-6CAA-05CA-44B6-FE3D30F2E652}"/>
+              </a:ext>
+            </a:extLst>
+          </p:cNvPr>
+          <p:cNvSpPr>
+            <a:spLocks noGrp="1"/>
+          </p:cNvSpPr>
+          <p:nvPr>
+            <p:ph idx="1"/>
+          </p:nvPr>
+        </p:nvSpPr>
+        <p:spPr/>
+        <p:txBody>
+          <a:bodyPr/>
+          <a:lstStyle/>
+          <a:p>
+            <a:r>
+              <a:rPr lang="zh-CN" altLang="en-US" dirty="0"/>
+              <a:t>第一个种子：</a:t>
+            </a:r>
+            <a:endParaRPr lang="en-US" altLang="zh-CN" dirty="0"/>
+          </a:p>
+          <a:p>
+            <a:endParaRPr lang="en-US" altLang="zh-CN" dirty="0"/>
+          </a:p>
+          <a:p>
+            <a:endParaRPr lang="en-US" altLang="zh-CN" dirty="0"/>
+          </a:p>
+          <a:p>
+            <a:endParaRPr lang="en-US" altLang="zh-CN" dirty="0"/>
+          </a:p>
+          <a:p>
+            <a:pPr lvl="0"/>
+            <a:r>
+              <a:rPr lang="zh-CN" altLang="zh-CN" dirty="0"/>
+              <a:t>GCN：更强烈地压缩和重建，干净图损失较大，但PGD去除能力强。</a:t>
+            </a:r>
+          </a:p>
+          <a:p>
+            <a:pPr lvl="0"/>
+            <a:r>
+              <a:rPr lang="zh-CN" altLang="zh-CN" dirty="0"/>
+              <a:t>FlowPure：更接近恒等映射，干净图保持更好，但也更容易残留攻击信号</a:t>
+            </a:r>
+          </a:p>
+          <a:p>
+            <a:endParaRPr lang="zh-CN" altLang="en-US" dirty="0"/>
+          </a:p>
+        </p:txBody>
+      </p:sp>
+      <p:graphicFrame>
+        <p:nvGraphicFramePr>
+          <p:cNvPr id="4" name="表格 3">
+            <a:extLst>
+              <a:ext uri="{FF2B5EF4-FFF2-40B4-BE49-F238E27FC236}">
+                <a16:creationId xmlns:a16="http://schemas.microsoft.com/office/drawing/2014/main" id="{C36548CD-0623-FB45-E35B-2353700E3950}"/>
+              </a:ext>
+            </a:extLst>
+          </p:cNvPr>
+          <p:cNvGraphicFramePr>
+            <a:graphicFrameLocks noGrp="1"/>
+          </p:cNvGraphicFramePr>
+          <p:nvPr>
+            <p:extLst>
+              <p:ext uri="{D42A27DB-BD31-4B8C-83A1-F6EECF244321}">
+                <p14:modId xmlns:p14="http://schemas.microsoft.com/office/powerpoint/2010/main" val="1333167509"/>
+              </p:ext>
+            </p:extLst>
+          </p:nvPr>
+        </p:nvGraphicFramePr>
+        <p:xfrm>
+          <a:off x="838200" y="2262846"/>
+          <a:ext cx="10515600" cy="1463040"/>
+        </p:xfrm>
+        <a:graphic>
+          <a:graphicData uri="http://schemas.openxmlformats.org/drawingml/2006/table">
+            <a:tbl>
+              <a:tblPr>
+                <a:tableStyleId>{5C22544A-7EE6-4342-B048-85BDC9FD1C3A}</a:tableStyleId>
+              </a:tblPr>
+              <a:tblGrid>
+                <a:gridCol w="3505200">
+                  <a:extLst>
+                    <a:ext uri="{9D8B030D-6E8A-4147-A177-3AD203B41FA5}">
+                      <a16:colId xmlns:a16="http://schemas.microsoft.com/office/drawing/2014/main" val="2694362265"/>
+                    </a:ext>
+                  </a:extLst>
+                </a:gridCol>
+                <a:gridCol w="3505200">
+                  <a:extLst>
+                    <a:ext uri="{9D8B030D-6E8A-4147-A177-3AD203B41FA5}">
+                      <a16:colId xmlns:a16="http://schemas.microsoft.com/office/drawing/2014/main" val="1895301889"/>
+                    </a:ext>
+                  </a:extLst>
+                </a:gridCol>
+                <a:gridCol w="3505200">
+                  <a:extLst>
+                    <a:ext uri="{9D8B030D-6E8A-4147-A177-3AD203B41FA5}">
+                      <a16:colId xmlns:a16="http://schemas.microsoft.com/office/drawing/2014/main" val="1677490956"/>
+                    </a:ext>
+                  </a:extLst>
+                </a:gridCol>
+              </a:tblGrid>
+              <a:tr h="0">
+                <a:tc>
+                  <a:txBody>
+                    <a:bodyPr/>
+                    <a:lstStyle/>
+                    <a:p>
+                      <a:pPr>
+                        <a:buNone/>
+                      </a:pPr>
+                      <a:r>
+                        <a:rPr lang="zh-CN"/>
+                        <a:t>方法</a:t>
+                      </a:r>
+                    </a:p>
+                  </a:txBody>
+                  <a:tcPr anchor="ctr"/>
+                </a:tc>
+                <a:tc>
+                  <a:txBody>
+                    <a:bodyPr/>
+                    <a:lstStyle/>
+                    <a:p>
+                      <a:pPr>
+                        <a:buNone/>
+                      </a:pPr>
+                      <a:r>
+                        <a:rPr lang="zh-CN"/>
+                        <a:t>mAP50恢复率</a:t>
+                      </a:r>
+                    </a:p>
+                  </a:txBody>
+                  <a:tcPr anchor="ctr"/>
+                </a:tc>
+                <a:tc>
+                  <a:txBody>
+                    <a:bodyPr/>
+                    <a:lstStyle/>
+                    <a:p>
+                      <a:pPr>
+                        <a:buNone/>
+                      </a:pPr>
+                      <a:r>
+                        <a:rPr lang="zh-CN"/>
+                        <a:t>mAP50-95恢复率</a:t>
+                      </a:r>
+                    </a:p>
+                  </a:txBody>
+                  <a:tcPr anchor="ctr"/>
+                </a:tc>
+                <a:extLst>
+                  <a:ext uri="{0D108BD9-81ED-4DB2-BD59-A6C34878D82A}">
+                    <a16:rowId xmlns:a16="http://schemas.microsoft.com/office/drawing/2014/main" val="3601921819"/>
+                  </a:ext>
+                </a:extLst>
+              </a:tr>
+              <a:tr h="0">
+                <a:tc>
+                  <a:txBody>
+                    <a:bodyPr/>
+                    <a:lstStyle/>
+                    <a:p>
+                      <a:pPr>
+                        <a:buNone/>
+                      </a:pPr>
+                      <a:r>
+                        <a:rPr lang="zh-CN"/>
+                        <a:t>GCN direct</a:t>
+                      </a:r>
+                    </a:p>
+                  </a:txBody>
+                  <a:tcPr anchor="ctr"/>
+                </a:tc>
+                <a:tc>
+                  <a:txBody>
+                    <a:bodyPr/>
+                    <a:lstStyle/>
+                    <a:p>
+                      <a:pPr>
+                        <a:buNone/>
+                      </a:pPr>
+                      <a:r>
+                        <a:rPr lang="zh-CN"/>
+                        <a:t>64.8%</a:t>
+                      </a:r>
+                    </a:p>
+                  </a:txBody>
+                  <a:tcPr anchor="ctr"/>
+                </a:tc>
+                <a:tc>
+                  <a:txBody>
+                    <a:bodyPr/>
+                    <a:lstStyle/>
+                    <a:p>
+                      <a:pPr>
+                        <a:buNone/>
+                      </a:pPr>
+                      <a:r>
+                        <a:rPr lang="zh-CN"/>
+                        <a:t>60.5%</a:t>
+                      </a:r>
+                    </a:p>
+                  </a:txBody>
+                  <a:tcPr anchor="ctr"/>
+                </a:tc>
+                <a:extLst>
+                  <a:ext uri="{0D108BD9-81ED-4DB2-BD59-A6C34878D82A}">
+                    <a16:rowId xmlns:a16="http://schemas.microsoft.com/office/drawing/2014/main" val="673188154"/>
+                  </a:ext>
+                </a:extLst>
+              </a:tr>
+              <a:tr h="0">
+                <a:tc>
+                  <a:txBody>
+                    <a:bodyPr/>
+                    <a:lstStyle/>
+                    <a:p>
+                      <a:pPr>
+                        <a:buNone/>
+                      </a:pPr>
+                      <a:r>
+                        <a:rPr lang="zh-CN"/>
+                        <a:t>GCN + diffusion，T*=3</a:t>
+                      </a:r>
+                    </a:p>
+                  </a:txBody>
+                  <a:tcPr anchor="ctr"/>
+                </a:tc>
+                <a:tc>
+                  <a:txBody>
+                    <a:bodyPr/>
+                    <a:lstStyle/>
+                    <a:p>
+                      <a:pPr>
+                        <a:buNone/>
+                      </a:pPr>
+                      <a:r>
+                        <a:rPr lang="zh-CN"/>
+                        <a:t>64.3%</a:t>
+                      </a:r>
+                    </a:p>
+                  </a:txBody>
+                  <a:tcPr anchor="ctr"/>
+                </a:tc>
+                <a:tc>
+                  <a:txBody>
+                    <a:bodyPr/>
+                    <a:lstStyle/>
+                    <a:p>
+                      <a:pPr>
+                        <a:buNone/>
+                      </a:pPr>
+                      <a:r>
+                        <a:rPr lang="zh-CN"/>
+                        <a:t>59.4%</a:t>
+                      </a:r>
+                    </a:p>
+                  </a:txBody>
+                  <a:tcPr anchor="ctr"/>
+                </a:tc>
+                <a:extLst>
+                  <a:ext uri="{0D108BD9-81ED-4DB2-BD59-A6C34878D82A}">
+                    <a16:rowId xmlns:a16="http://schemas.microsoft.com/office/drawing/2014/main" val="815459856"/>
+                  </a:ext>
+                </a:extLst>
+              </a:tr>
+              <a:tr h="0">
+                <a:tc>
+                  <a:txBody>
+                    <a:bodyPr/>
+                    <a:lstStyle/>
+                    <a:p>
+                      <a:pPr>
+                        <a:buNone/>
+                      </a:pPr>
+                      <a:r>
+                        <a:rPr lang="zh-CN"/>
+                        <a:t>FlowPure-2000</a:t>
+                      </a:r>
+                    </a:p>
+                  </a:txBody>
+                  <a:tcPr anchor="ctr"/>
+                </a:tc>
+                <a:tc>
+                  <a:txBody>
+                    <a:bodyPr/>
+                    <a:lstStyle/>
+                    <a:p>
+                      <a:pPr>
+                        <a:buNone/>
+                      </a:pPr>
+                      <a:r>
+                        <a:rPr lang="zh-CN"/>
+                        <a:t>39.9%</a:t>
+                      </a:r>
+                    </a:p>
+                  </a:txBody>
+                  <a:tcPr anchor="ctr"/>
+                </a:tc>
+                <a:tc>
+                  <a:txBody>
+                    <a:bodyPr/>
+                    <a:lstStyle/>
+                    <a:p>
+                      <a:pPr>
+                        <a:buNone/>
+                      </a:pPr>
+                      <a:r>
+                        <a:rPr lang="zh-CN" dirty="0"/>
+                        <a:t>35.6%</a:t>
+                      </a:r>
+                    </a:p>
+                  </a:txBody>
+                  <a:tcPr anchor="ctr"/>
+                </a:tc>
+                <a:extLst>
+                  <a:ext uri="{0D108BD9-81ED-4DB2-BD59-A6C34878D82A}">
+                    <a16:rowId xmlns:a16="http://schemas.microsoft.com/office/drawing/2014/main" val="3206036406"/>
+                  </a:ext>
+                </a:extLst>
+              </a:tr>
+            </a:tbl>
+          </a:graphicData>
+        </a:graphic>
+      </p:graphicFrame>
+    </p:spTree>
+    <p:extLst>
+      <p:ext uri="{BB962C8B-B14F-4D97-AF65-F5344CB8AC3E}">
+        <p14:creationId xmlns:p14="http://schemas.microsoft.com/office/powerpoint/2010/main" val="1627048911"/>
+      </p:ext>
+    </p:extLst>
+  </p:cSld>
+  <p:clrMapOvr>
+    <a:masterClrMapping/>
+  </p:clrMapOvr>
+</p:sld>
+</file>
+
+<file path=ppt/slides/slide7.xml><?xml version="1.0" encoding="utf-8"?>
+<p:sld xmlns:a="http://schemas.openxmlformats.org/drawingml/2006/main" xmlns:r="http://schemas.openxmlformats.org/officeDocument/2006/relationships" xmlns:p="http://schemas.openxmlformats.org/presentationml/2006/main">
+  <p:cSld>
+    <p:spTree>
+      <p:nvGrpSpPr>
+        <p:cNvPr id="1" name=""/>
+        <p:cNvGrpSpPr/>
+        <p:nvPr/>
+      </p:nvGrpSpPr>
+      <p:grpSpPr>
+        <a:xfrm>
+          <a:off x="0" y="0"/>
+          <a:ext cx="0" cy="0"/>
+          <a:chOff x="0" y="0"/>
+          <a:chExt cx="0" cy="0"/>
+        </a:xfrm>
+      </p:grpSpPr>
+      <p:sp>
+        <p:nvSpPr>
+          <p:cNvPr id="2" name="标题 1">
+            <a:extLst>
+              <a:ext uri="{FF2B5EF4-FFF2-40B4-BE49-F238E27FC236}">
+                <a16:creationId xmlns:a16="http://schemas.microsoft.com/office/drawing/2014/main" id="{2B7CAE79-8E6C-313B-E575-A1546917BD57}"/>
+              </a:ext>
+            </a:extLst>
+          </p:cNvPr>
+          <p:cNvSpPr>
+            <a:spLocks noGrp="1"/>
+          </p:cNvSpPr>
+          <p:nvPr>
+            <p:ph type="title"/>
+          </p:nvPr>
+        </p:nvSpPr>
+        <p:spPr/>
+        <p:txBody>
+          <a:bodyPr/>
+          <a:lstStyle/>
+          <a:p>
+            <a:endParaRPr lang="zh-CN" altLang="en-US"/>
+          </a:p>
+        </p:txBody>
+      </p:sp>
+      <p:graphicFrame>
+        <p:nvGraphicFramePr>
+          <p:cNvPr id="4" name="内容占位符 3">
+            <a:extLst>
+              <a:ext uri="{FF2B5EF4-FFF2-40B4-BE49-F238E27FC236}">
+                <a16:creationId xmlns:a16="http://schemas.microsoft.com/office/drawing/2014/main" id="{D9981D77-EF4A-3CBD-1521-5FDDFCBB547D}"/>
+              </a:ext>
+            </a:extLst>
+          </p:cNvPr>
+          <p:cNvGraphicFramePr>
+            <a:graphicFrameLocks noGrp="1"/>
+          </p:cNvGraphicFramePr>
+          <p:nvPr>
+            <p:ph idx="1"/>
+            <p:extLst>
+              <p:ext uri="{D42A27DB-BD31-4B8C-83A1-F6EECF244321}">
+                <p14:modId xmlns:p14="http://schemas.microsoft.com/office/powerpoint/2010/main" val="1438042718"/>
+              </p:ext>
+            </p:extLst>
+          </p:nvPr>
+        </p:nvGraphicFramePr>
+        <p:xfrm>
+          <a:off x="838200" y="1690688"/>
+          <a:ext cx="10515600" cy="1463040"/>
+        </p:xfrm>
+        <a:graphic>
+          <a:graphicData uri="http://schemas.openxmlformats.org/drawingml/2006/table">
+            <a:tbl>
+              <a:tblPr>
+                <a:tableStyleId>{5C22544A-7EE6-4342-B048-85BDC9FD1C3A}</a:tableStyleId>
+              </a:tblPr>
+              <a:tblGrid>
+                <a:gridCol w="2628900">
+                  <a:extLst>
+                    <a:ext uri="{9D8B030D-6E8A-4147-A177-3AD203B41FA5}">
+                      <a16:colId xmlns:a16="http://schemas.microsoft.com/office/drawing/2014/main" val="1858862528"/>
+                    </a:ext>
+                  </a:extLst>
+                </a:gridCol>
+                <a:gridCol w="2628900">
+                  <a:extLst>
+                    <a:ext uri="{9D8B030D-6E8A-4147-A177-3AD203B41FA5}">
+                      <a16:colId xmlns:a16="http://schemas.microsoft.com/office/drawing/2014/main" val="3217184522"/>
+                    </a:ext>
+                  </a:extLst>
+                </a:gridCol>
+                <a:gridCol w="2628900">
+                  <a:extLst>
+                    <a:ext uri="{9D8B030D-6E8A-4147-A177-3AD203B41FA5}">
+                      <a16:colId xmlns:a16="http://schemas.microsoft.com/office/drawing/2014/main" val="286183100"/>
+                    </a:ext>
+                  </a:extLst>
+                </a:gridCol>
+                <a:gridCol w="2628900">
+                  <a:extLst>
+                    <a:ext uri="{9D8B030D-6E8A-4147-A177-3AD203B41FA5}">
+                      <a16:colId xmlns:a16="http://schemas.microsoft.com/office/drawing/2014/main" val="3712731754"/>
+                    </a:ext>
+                  </a:extLst>
+                </a:gridCol>
+              </a:tblGrid>
+              <a:tr h="0">
+                <a:tc>
+                  <a:txBody>
+                    <a:bodyPr/>
+                    <a:lstStyle/>
+                    <a:p>
+                      <a:pPr>
+                        <a:buNone/>
+                      </a:pPr>
+                      <a:r>
+                        <a:rPr lang="zh-CN"/>
+                        <a:t>PGD seed</a:t>
+                      </a:r>
+                    </a:p>
+                  </a:txBody>
+                  <a:tcPr anchor="ctr"/>
+                </a:tc>
+                <a:tc>
+                  <a:txBody>
+                    <a:bodyPr/>
+                    <a:lstStyle/>
+                    <a:p>
+                      <a:pPr>
+                        <a:buNone/>
+                      </a:pPr>
+                      <a:r>
+                        <a:rPr lang="zh-CN"/>
+                        <a:t>GCN direct</a:t>
+                      </a:r>
+                    </a:p>
+                  </a:txBody>
+                  <a:tcPr anchor="ctr"/>
+                </a:tc>
+                <a:tc>
+                  <a:txBody>
+                    <a:bodyPr/>
+                    <a:lstStyle/>
+                    <a:p>
+                      <a:pPr>
+                        <a:buNone/>
+                      </a:pPr>
+                      <a:r>
+                        <a:rPr lang="zh-CN"/>
+                        <a:t>GCN T*=3</a:t>
+                      </a:r>
+                    </a:p>
+                  </a:txBody>
+                  <a:tcPr anchor="ctr"/>
+                </a:tc>
+                <a:tc>
+                  <a:txBody>
+                    <a:bodyPr/>
+                    <a:lstStyle/>
+                    <a:p>
+                      <a:pPr>
+                        <a:buNone/>
+                      </a:pPr>
+                      <a:r>
+                        <a:rPr lang="zh-CN"/>
+                        <a:t>FlowPure</a:t>
+                      </a:r>
+                    </a:p>
+                  </a:txBody>
+                  <a:tcPr anchor="ctr"/>
+                </a:tc>
+                <a:extLst>
+                  <a:ext uri="{0D108BD9-81ED-4DB2-BD59-A6C34878D82A}">
+                    <a16:rowId xmlns:a16="http://schemas.microsoft.com/office/drawing/2014/main" val="362175609"/>
+                  </a:ext>
+                </a:extLst>
+              </a:tr>
+              <a:tr h="0">
+                <a:tc>
+                  <a:txBody>
+                    <a:bodyPr/>
+                    <a:lstStyle/>
+                    <a:p>
+                      <a:pPr>
+                        <a:buNone/>
+                      </a:pPr>
+                      <a:r>
+                        <a:rPr lang="zh-CN"/>
+                        <a:t>20260822</a:t>
+                      </a:r>
+                    </a:p>
+                  </a:txBody>
+                  <a:tcPr anchor="ctr"/>
+                </a:tc>
+                <a:tc>
+                  <a:txBody>
+                    <a:bodyPr/>
+                    <a:lstStyle/>
+                    <a:p>
+                      <a:pPr>
+                        <a:buNone/>
+                      </a:pPr>
+                      <a:r>
+                        <a:rPr lang="zh-CN"/>
+                        <a:t>64.8%</a:t>
+                      </a:r>
+                    </a:p>
+                  </a:txBody>
+                  <a:tcPr anchor="ctr"/>
+                </a:tc>
+                <a:tc>
+                  <a:txBody>
+                    <a:bodyPr/>
+                    <a:lstStyle/>
+                    <a:p>
+                      <a:pPr>
+                        <a:buNone/>
+                      </a:pPr>
+                      <a:r>
+                        <a:rPr lang="zh-CN"/>
+                        <a:t>64.3%</a:t>
+                      </a:r>
+                    </a:p>
+                  </a:txBody>
+                  <a:tcPr anchor="ctr"/>
+                </a:tc>
+                <a:tc>
+                  <a:txBody>
+                    <a:bodyPr/>
+                    <a:lstStyle/>
+                    <a:p>
+                      <a:pPr>
+                        <a:buNone/>
+                      </a:pPr>
+                      <a:r>
+                        <a:rPr lang="zh-CN"/>
+                        <a:t>39.9%</a:t>
+                      </a:r>
+                    </a:p>
+                  </a:txBody>
+                  <a:tcPr anchor="ctr"/>
+                </a:tc>
+                <a:extLst>
+                  <a:ext uri="{0D108BD9-81ED-4DB2-BD59-A6C34878D82A}">
+                    <a16:rowId xmlns:a16="http://schemas.microsoft.com/office/drawing/2014/main" val="2712261971"/>
+                  </a:ext>
+                </a:extLst>
+              </a:tr>
+              <a:tr h="0">
+                <a:tc>
+                  <a:txBody>
+                    <a:bodyPr/>
+                    <a:lstStyle/>
+                    <a:p>
+                      <a:pPr>
+                        <a:buNone/>
+                      </a:pPr>
+                      <a:r>
+                        <a:rPr lang="zh-CN"/>
+                        <a:t>20260823</a:t>
+                      </a:r>
+                    </a:p>
+                  </a:txBody>
+                  <a:tcPr anchor="ctr"/>
+                </a:tc>
+                <a:tc>
+                  <a:txBody>
+                    <a:bodyPr/>
+                    <a:lstStyle/>
+                    <a:p>
+                      <a:pPr>
+                        <a:buNone/>
+                      </a:pPr>
+                      <a:r>
+                        <a:rPr lang="zh-CN"/>
+                        <a:t>64.6%</a:t>
+                      </a:r>
+                    </a:p>
+                  </a:txBody>
+                  <a:tcPr anchor="ctr"/>
+                </a:tc>
+                <a:tc>
+                  <a:txBody>
+                    <a:bodyPr/>
+                    <a:lstStyle/>
+                    <a:p>
+                      <a:pPr>
+                        <a:buNone/>
+                      </a:pPr>
+                      <a:r>
+                        <a:rPr lang="zh-CN"/>
+                        <a:t>63.8%</a:t>
+                      </a:r>
+                    </a:p>
+                  </a:txBody>
+                  <a:tcPr anchor="ctr"/>
+                </a:tc>
+                <a:tc>
+                  <a:txBody>
+                    <a:bodyPr/>
+                    <a:lstStyle/>
+                    <a:p>
+                      <a:pPr>
+                        <a:buNone/>
+                      </a:pPr>
+                      <a:r>
+                        <a:rPr lang="zh-CN"/>
+                        <a:t>40.5%</a:t>
+                      </a:r>
+                    </a:p>
+                  </a:txBody>
+                  <a:tcPr anchor="ctr"/>
+                </a:tc>
+                <a:extLst>
+                  <a:ext uri="{0D108BD9-81ED-4DB2-BD59-A6C34878D82A}">
+                    <a16:rowId xmlns:a16="http://schemas.microsoft.com/office/drawing/2014/main" val="1765386872"/>
+                  </a:ext>
+                </a:extLst>
+              </a:tr>
+              <a:tr h="0">
+                <a:tc>
+                  <a:txBody>
+                    <a:bodyPr/>
+                    <a:lstStyle/>
+                    <a:p>
+                      <a:pPr>
+                        <a:buNone/>
+                      </a:pPr>
+                      <a:r>
+                        <a:rPr lang="zh-CN"/>
+                        <a:t>20260824</a:t>
+                      </a:r>
+                    </a:p>
+                  </a:txBody>
+                  <a:tcPr anchor="ctr"/>
+                </a:tc>
+                <a:tc>
+                  <a:txBody>
+                    <a:bodyPr/>
+                    <a:lstStyle/>
+                    <a:p>
+                      <a:pPr>
+                        <a:buNone/>
+                      </a:pPr>
+                      <a:r>
+                        <a:rPr lang="zh-CN"/>
+                        <a:t>64.6%</a:t>
+                      </a:r>
+                    </a:p>
+                  </a:txBody>
+                  <a:tcPr anchor="ctr"/>
+                </a:tc>
+                <a:tc>
+                  <a:txBody>
+                    <a:bodyPr/>
+                    <a:lstStyle/>
+                    <a:p>
+                      <a:pPr>
+                        <a:buNone/>
+                      </a:pPr>
+                      <a:r>
+                        <a:rPr lang="zh-CN"/>
+                        <a:t>64.4%</a:t>
+                      </a:r>
+                    </a:p>
+                  </a:txBody>
+                  <a:tcPr anchor="ctr"/>
+                </a:tc>
+                <a:tc>
+                  <a:txBody>
+                    <a:bodyPr/>
+                    <a:lstStyle/>
+                    <a:p>
+                      <a:pPr>
+                        <a:buNone/>
+                      </a:pPr>
+                      <a:r>
+                        <a:rPr lang="zh-CN" dirty="0"/>
+                        <a:t>40.2%</a:t>
+                      </a:r>
+                    </a:p>
+                  </a:txBody>
+                  <a:tcPr anchor="ctr"/>
+                </a:tc>
+                <a:extLst>
+                  <a:ext uri="{0D108BD9-81ED-4DB2-BD59-A6C34878D82A}">
+                    <a16:rowId xmlns:a16="http://schemas.microsoft.com/office/drawing/2014/main" val="1789451793"/>
+                  </a:ext>
+                </a:extLst>
+              </a:tr>
+            </a:tbl>
+          </a:graphicData>
+        </a:graphic>
+      </p:graphicFrame>
+      <p:graphicFrame>
+        <p:nvGraphicFramePr>
+          <p:cNvPr id="5" name="表格 4">
+            <a:extLst>
+              <a:ext uri="{FF2B5EF4-FFF2-40B4-BE49-F238E27FC236}">
+                <a16:creationId xmlns:a16="http://schemas.microsoft.com/office/drawing/2014/main" id="{C41A0BAF-6D7A-EE8B-88F0-834B7A63082E}"/>
+              </a:ext>
+            </a:extLst>
+          </p:cNvPr>
+          <p:cNvGraphicFramePr>
+            <a:graphicFrameLocks noGrp="1"/>
+          </p:cNvGraphicFramePr>
+          <p:nvPr/>
+        </p:nvGraphicFramePr>
+        <p:xfrm>
+          <a:off x="838200" y="3269774"/>
+          <a:ext cx="10515600" cy="1463040"/>
+        </p:xfrm>
+        <a:graphic>
+          <a:graphicData uri="http://schemas.openxmlformats.org/drawingml/2006/table">
+            <a:tbl>
+              <a:tblPr>
+                <a:tableStyleId>{5C22544A-7EE6-4342-B048-85BDC9FD1C3A}</a:tableStyleId>
+              </a:tblPr>
+              <a:tblGrid>
+                <a:gridCol w="3505200">
+                  <a:extLst>
+                    <a:ext uri="{9D8B030D-6E8A-4147-A177-3AD203B41FA5}">
+                      <a16:colId xmlns:a16="http://schemas.microsoft.com/office/drawing/2014/main" val="196172479"/>
+                    </a:ext>
+                  </a:extLst>
+                </a:gridCol>
+                <a:gridCol w="3505200">
+                  <a:extLst>
+                    <a:ext uri="{9D8B030D-6E8A-4147-A177-3AD203B41FA5}">
+                      <a16:colId xmlns:a16="http://schemas.microsoft.com/office/drawing/2014/main" val="3859962293"/>
+                    </a:ext>
+                  </a:extLst>
+                </a:gridCol>
+                <a:gridCol w="3505200">
+                  <a:extLst>
+                    <a:ext uri="{9D8B030D-6E8A-4147-A177-3AD203B41FA5}">
+                      <a16:colId xmlns:a16="http://schemas.microsoft.com/office/drawing/2014/main" val="3588470580"/>
+                    </a:ext>
+                  </a:extLst>
+                </a:gridCol>
+              </a:tblGrid>
+              <a:tr h="0">
+                <a:tc>
+                  <a:txBody>
+                    <a:bodyPr/>
+                    <a:lstStyle/>
+                    <a:p>
+                      <a:pPr>
+                        <a:buNone/>
+                      </a:pPr>
+                      <a:r>
+                        <a:rPr lang="zh-CN"/>
+                        <a:t>方法</a:t>
+                      </a:r>
+                    </a:p>
+                  </a:txBody>
+                  <a:tcPr anchor="ctr"/>
+                </a:tc>
+                <a:tc>
+                  <a:txBody>
+                    <a:bodyPr/>
+                    <a:lstStyle/>
+                    <a:p>
+                      <a:pPr>
+                        <a:buNone/>
+                      </a:pPr>
+                      <a:r>
+                        <a:rPr lang="zh-CN"/>
+                        <a:t>最低mAP50恢复率</a:t>
+                      </a:r>
+                    </a:p>
+                  </a:txBody>
+                  <a:tcPr anchor="ctr"/>
+                </a:tc>
+                <a:tc>
+                  <a:txBody>
+                    <a:bodyPr/>
+                    <a:lstStyle/>
+                    <a:p>
+                      <a:pPr>
+                        <a:buNone/>
+                      </a:pPr>
+                      <a:r>
+                        <a:rPr lang="zh-CN"/>
+                        <a:t>最低mAP50-95恢复率</a:t>
+                      </a:r>
+                    </a:p>
+                  </a:txBody>
+                  <a:tcPr anchor="ctr"/>
+                </a:tc>
+                <a:extLst>
+                  <a:ext uri="{0D108BD9-81ED-4DB2-BD59-A6C34878D82A}">
+                    <a16:rowId xmlns:a16="http://schemas.microsoft.com/office/drawing/2014/main" val="1117328521"/>
+                  </a:ext>
+                </a:extLst>
+              </a:tr>
+              <a:tr h="0">
+                <a:tc>
+                  <a:txBody>
+                    <a:bodyPr/>
+                    <a:lstStyle/>
+                    <a:p>
+                      <a:pPr>
+                        <a:buNone/>
+                      </a:pPr>
+                      <a:r>
+                        <a:rPr lang="zh-CN"/>
+                        <a:t>GCN direct</a:t>
+                      </a:r>
+                    </a:p>
+                  </a:txBody>
+                  <a:tcPr anchor="ctr"/>
+                </a:tc>
+                <a:tc>
+                  <a:txBody>
+                    <a:bodyPr/>
+                    <a:lstStyle/>
+                    <a:p>
+                      <a:pPr>
+                        <a:buNone/>
+                      </a:pPr>
+                      <a:r>
+                        <a:rPr lang="zh-CN"/>
+                        <a:t>64.6%</a:t>
+                      </a:r>
+                    </a:p>
+                  </a:txBody>
+                  <a:tcPr anchor="ctr"/>
+                </a:tc>
+                <a:tc>
+                  <a:txBody>
+                    <a:bodyPr/>
+                    <a:lstStyle/>
+                    <a:p>
+                      <a:pPr>
+                        <a:buNone/>
+                      </a:pPr>
+                      <a:r>
+                        <a:rPr lang="zh-CN"/>
+                        <a:t>60.2%</a:t>
+                      </a:r>
+                    </a:p>
+                  </a:txBody>
+                  <a:tcPr anchor="ctr"/>
+                </a:tc>
+                <a:extLst>
+                  <a:ext uri="{0D108BD9-81ED-4DB2-BD59-A6C34878D82A}">
+                    <a16:rowId xmlns:a16="http://schemas.microsoft.com/office/drawing/2014/main" val="2261266088"/>
+                  </a:ext>
+                </a:extLst>
+              </a:tr>
+              <a:tr h="0">
+                <a:tc>
+                  <a:txBody>
+                    <a:bodyPr/>
+                    <a:lstStyle/>
+                    <a:p>
+                      <a:pPr>
+                        <a:buNone/>
+                      </a:pPr>
+                      <a:r>
+                        <a:rPr lang="zh-CN"/>
+                        <a:t>GCN T*=3</a:t>
+                      </a:r>
+                    </a:p>
+                  </a:txBody>
+                  <a:tcPr anchor="ctr"/>
+                </a:tc>
+                <a:tc>
+                  <a:txBody>
+                    <a:bodyPr/>
+                    <a:lstStyle/>
+                    <a:p>
+                      <a:pPr>
+                        <a:buNone/>
+                      </a:pPr>
+                      <a:r>
+                        <a:rPr lang="zh-CN"/>
+                        <a:t>63.8%</a:t>
+                      </a:r>
+                    </a:p>
+                  </a:txBody>
+                  <a:tcPr anchor="ctr"/>
+                </a:tc>
+                <a:tc>
+                  <a:txBody>
+                    <a:bodyPr/>
+                    <a:lstStyle/>
+                    <a:p>
+                      <a:pPr>
+                        <a:buNone/>
+                      </a:pPr>
+                      <a:r>
+                        <a:rPr lang="zh-CN"/>
+                        <a:t>59.1%</a:t>
+                      </a:r>
+                    </a:p>
+                  </a:txBody>
+                  <a:tcPr anchor="ctr"/>
+                </a:tc>
+                <a:extLst>
+                  <a:ext uri="{0D108BD9-81ED-4DB2-BD59-A6C34878D82A}">
+                    <a16:rowId xmlns:a16="http://schemas.microsoft.com/office/drawing/2014/main" val="394471994"/>
+                  </a:ext>
+                </a:extLst>
+              </a:tr>
+              <a:tr h="0">
+                <a:tc>
+                  <a:txBody>
+                    <a:bodyPr/>
+                    <a:lstStyle/>
+                    <a:p>
+                      <a:pPr>
+                        <a:buNone/>
+                      </a:pPr>
+                      <a:r>
+                        <a:rPr lang="zh-CN"/>
+                        <a:t>FlowPure</a:t>
+                      </a:r>
+                    </a:p>
+                  </a:txBody>
+                  <a:tcPr anchor="ctr"/>
+                </a:tc>
+                <a:tc>
+                  <a:txBody>
+                    <a:bodyPr/>
+                    <a:lstStyle/>
+                    <a:p>
+                      <a:pPr>
+                        <a:buNone/>
+                      </a:pPr>
+                      <a:r>
+                        <a:rPr lang="zh-CN"/>
+                        <a:t>39.9%</a:t>
+                      </a:r>
+                    </a:p>
+                  </a:txBody>
+                  <a:tcPr anchor="ctr"/>
+                </a:tc>
+                <a:tc>
+                  <a:txBody>
+                    <a:bodyPr/>
+                    <a:lstStyle/>
+                    <a:p>
+                      <a:pPr>
+                        <a:buNone/>
+                      </a:pPr>
+                      <a:r>
+                        <a:rPr lang="zh-CN" dirty="0"/>
+                        <a:t>35.3%</a:t>
+                      </a:r>
+                    </a:p>
+                  </a:txBody>
+                  <a:tcPr anchor="ctr"/>
+                </a:tc>
+                <a:extLst>
+                  <a:ext uri="{0D108BD9-81ED-4DB2-BD59-A6C34878D82A}">
+                    <a16:rowId xmlns:a16="http://schemas.microsoft.com/office/drawing/2014/main" val="1334036163"/>
+                  </a:ext>
+                </a:extLst>
+              </a:tr>
+            </a:tbl>
+          </a:graphicData>
+        </a:graphic>
+      </p:graphicFrame>
+    </p:spTree>
+    <p:extLst>
+      <p:ext uri="{BB962C8B-B14F-4D97-AF65-F5344CB8AC3E}">
+        <p14:creationId xmlns:p14="http://schemas.microsoft.com/office/powerpoint/2010/main" val="571337373"/>
+      </p:ext>
+    </p:extLst>
+  </p:cSld>
+  <p:clrMapOvr>
+    <a:masterClrMapping/>
+  </p:clrMapOvr>
+</p:sld>
+</file>
+
 <file path=ppt/theme/theme1.xml><?xml version="1.0" encoding="utf-8"?>
 <a:theme xmlns:a="http://schemas.openxmlformats.org/drawingml/2006/main" name="Office 主题​​">
   <a:themeElements>

</xml_diff>